<commit_message>
fix: restore 8-tab architecture and fix HTML rendering for priority cards in Tab 8
</commit_message>
<xml_diff>
--- a/DataViz Sample PPT Template.pptx
+++ b/DataViz Sample PPT Template.pptx
@@ -275,6 +275,13 @@
           </p:nvPr>
         </p:nvSpPr>
         <p:spPr/>
+        <p:txBody>
+          <a:bodyPr/>
+          <a:lstStyle/>
+          <a:p>
+            <a:endParaRPr lang="en-IN"/>
+          </a:p>
+        </p:txBody>
       </p:sp>
       <p:sp>
         <p:nvSpPr>
@@ -362,6 +369,13 @@
           </p:nvPr>
         </p:nvSpPr>
         <p:spPr/>
+        <p:txBody>
+          <a:bodyPr/>
+          <a:lstStyle/>
+          <a:p>
+            <a:endParaRPr lang="en-IN"/>
+          </a:p>
+        </p:txBody>
       </p:sp>
       <p:sp>
         <p:nvSpPr>
@@ -449,6 +463,13 @@
           </p:nvPr>
         </p:nvSpPr>
         <p:spPr/>
+        <p:txBody>
+          <a:bodyPr/>
+          <a:lstStyle/>
+          <a:p>
+            <a:endParaRPr lang="en-IN"/>
+          </a:p>
+        </p:txBody>
       </p:sp>
       <p:sp>
         <p:nvSpPr>
@@ -536,6 +557,13 @@
           </p:nvPr>
         </p:nvSpPr>
         <p:spPr/>
+        <p:txBody>
+          <a:bodyPr/>
+          <a:lstStyle/>
+          <a:p>
+            <a:endParaRPr lang="en-IN"/>
+          </a:p>
+        </p:txBody>
       </p:sp>
       <p:sp>
         <p:nvSpPr>
@@ -623,6 +651,13 @@
           </p:nvPr>
         </p:nvSpPr>
         <p:spPr/>
+        <p:txBody>
+          <a:bodyPr/>
+          <a:lstStyle/>
+          <a:p>
+            <a:endParaRPr lang="en-IN"/>
+          </a:p>
+        </p:txBody>
       </p:sp>
       <p:sp>
         <p:nvSpPr>
@@ -710,6 +745,13 @@
           </p:nvPr>
         </p:nvSpPr>
         <p:spPr/>
+        <p:txBody>
+          <a:bodyPr/>
+          <a:lstStyle/>
+          <a:p>
+            <a:endParaRPr lang="en-IN"/>
+          </a:p>
+        </p:txBody>
       </p:sp>
       <p:sp>
         <p:nvSpPr>
@@ -797,6 +839,13 @@
           </p:nvPr>
         </p:nvSpPr>
         <p:spPr/>
+        <p:txBody>
+          <a:bodyPr/>
+          <a:lstStyle/>
+          <a:p>
+            <a:endParaRPr lang="en-IN"/>
+          </a:p>
+        </p:txBody>
       </p:sp>
       <p:sp>
         <p:nvSpPr>
@@ -884,6 +933,13 @@
           </p:nvPr>
         </p:nvSpPr>
         <p:spPr/>
+        <p:txBody>
+          <a:bodyPr/>
+          <a:lstStyle/>
+          <a:p>
+            <a:endParaRPr lang="en-IN"/>
+          </a:p>
+        </p:txBody>
       </p:sp>
       <p:sp>
         <p:nvSpPr>
@@ -971,6 +1027,13 @@
           </p:nvPr>
         </p:nvSpPr>
         <p:spPr/>
+        <p:txBody>
+          <a:bodyPr/>
+          <a:lstStyle/>
+          <a:p>
+            <a:endParaRPr lang="en-IN"/>
+          </a:p>
+        </p:txBody>
       </p:sp>
       <p:sp>
         <p:nvSpPr>
@@ -1058,6 +1121,13 @@
           </p:nvPr>
         </p:nvSpPr>
         <p:spPr/>
+        <p:txBody>
+          <a:bodyPr/>
+          <a:lstStyle/>
+          <a:p>
+            <a:endParaRPr lang="en-IN"/>
+          </a:p>
+        </p:txBody>
       </p:sp>
       <p:sp>
         <p:nvSpPr>
@@ -1145,6 +1215,13 @@
           </p:nvPr>
         </p:nvSpPr>
         <p:spPr/>
+        <p:txBody>
+          <a:bodyPr/>
+          <a:lstStyle/>
+          <a:p>
+            <a:endParaRPr lang="en-IN"/>
+          </a:p>
+        </p:txBody>
       </p:sp>
       <p:sp>
         <p:nvSpPr>
@@ -1808,6 +1885,13 @@
           </a:gradFill>
           <a:ln/>
         </p:spPr>
+        <p:txBody>
+          <a:bodyPr/>
+          <a:lstStyle/>
+          <a:p>
+            <a:endParaRPr lang="en-IN"/>
+          </a:p>
+        </p:txBody>
       </p:sp>
       <p:sp>
         <p:nvSpPr>
@@ -1844,6 +1928,13 @@
           </a:gradFill>
           <a:ln/>
         </p:spPr>
+        <p:txBody>
+          <a:bodyPr/>
+          <a:lstStyle/>
+          <a:p>
+            <a:endParaRPr lang="en-IN"/>
+          </a:p>
+        </p:txBody>
       </p:sp>
       <p:sp>
         <p:nvSpPr>
@@ -2263,6 +2354,13 @@
           </a:gradFill>
           <a:ln/>
         </p:spPr>
+        <p:txBody>
+          <a:bodyPr/>
+          <a:lstStyle/>
+          <a:p>
+            <a:endParaRPr lang="en-IN"/>
+          </a:p>
+        </p:txBody>
       </p:sp>
       <p:sp>
         <p:nvSpPr>
@@ -2386,6 +2484,13 @@
             <a:prstDash val="solid"/>
           </a:ln>
         </p:spPr>
+        <p:txBody>
+          <a:bodyPr/>
+          <a:lstStyle/>
+          <a:p>
+            <a:endParaRPr lang="en-IN"/>
+          </a:p>
+        </p:txBody>
       </p:sp>
       <p:sp>
         <p:nvSpPr>
@@ -2549,6 +2654,13 @@
             <a:prstDash val="solid"/>
           </a:ln>
         </p:spPr>
+        <p:txBody>
+          <a:bodyPr/>
+          <a:lstStyle/>
+          <a:p>
+            <a:endParaRPr lang="en-IN"/>
+          </a:p>
+        </p:txBody>
       </p:sp>
       <p:sp>
         <p:nvSpPr>
@@ -2835,6 +2947,13 @@
           </a:gradFill>
           <a:ln/>
         </p:spPr>
+        <p:txBody>
+          <a:bodyPr/>
+          <a:lstStyle/>
+          <a:p>
+            <a:endParaRPr lang="en-IN"/>
+          </a:p>
+        </p:txBody>
       </p:sp>
       <p:sp>
         <p:nvSpPr>
@@ -2871,6 +2990,13 @@
           </a:gradFill>
           <a:ln/>
         </p:spPr>
+        <p:txBody>
+          <a:bodyPr/>
+          <a:lstStyle/>
+          <a:p>
+            <a:endParaRPr lang="en-IN"/>
+          </a:p>
+        </p:txBody>
       </p:sp>
       <p:sp>
         <p:nvSpPr>
@@ -3251,6 +3377,13 @@
           </a:gradFill>
           <a:ln/>
         </p:spPr>
+        <p:txBody>
+          <a:bodyPr/>
+          <a:lstStyle/>
+          <a:p>
+            <a:endParaRPr lang="en-IN"/>
+          </a:p>
+        </p:txBody>
       </p:sp>
       <p:sp>
         <p:nvSpPr>
@@ -3374,6 +3507,13 @@
             <a:prstDash val="solid"/>
           </a:ln>
         </p:spPr>
+        <p:txBody>
+          <a:bodyPr/>
+          <a:lstStyle/>
+          <a:p>
+            <a:endParaRPr lang="en-IN"/>
+          </a:p>
+        </p:txBody>
       </p:sp>
       <p:sp>
         <p:nvSpPr>
@@ -3493,6 +3633,13 @@
             <a:prstDash val="solid"/>
           </a:ln>
         </p:spPr>
+        <p:txBody>
+          <a:bodyPr/>
+          <a:lstStyle/>
+          <a:p>
+            <a:endParaRPr lang="en-IN"/>
+          </a:p>
+        </p:txBody>
       </p:sp>
       <p:sp>
         <p:nvSpPr>
@@ -3612,6 +3759,13 @@
             <a:prstDash val="solid"/>
           </a:ln>
         </p:spPr>
+        <p:txBody>
+          <a:bodyPr/>
+          <a:lstStyle/>
+          <a:p>
+            <a:endParaRPr lang="en-IN"/>
+          </a:p>
+        </p:txBody>
       </p:sp>
       <p:sp>
         <p:nvSpPr>
@@ -3723,6 +3877,13 @@
             <a:prstDash val="solid"/>
           </a:ln>
         </p:spPr>
+        <p:txBody>
+          <a:bodyPr/>
+          <a:lstStyle/>
+          <a:p>
+            <a:endParaRPr lang="en-IN"/>
+          </a:p>
+        </p:txBody>
       </p:sp>
       <p:sp>
         <p:nvSpPr>
@@ -3963,6 +4124,13 @@
           </a:gradFill>
           <a:ln/>
         </p:spPr>
+        <p:txBody>
+          <a:bodyPr/>
+          <a:lstStyle/>
+          <a:p>
+            <a:endParaRPr lang="en-IN"/>
+          </a:p>
+        </p:txBody>
       </p:sp>
       <p:sp>
         <p:nvSpPr>
@@ -4086,6 +4254,13 @@
             <a:prstDash val="solid"/>
           </a:ln>
         </p:spPr>
+        <p:txBody>
+          <a:bodyPr/>
+          <a:lstStyle/>
+          <a:p>
+            <a:endParaRPr lang="en-IN"/>
+          </a:p>
+        </p:txBody>
       </p:sp>
       <p:sp>
         <p:nvSpPr>
@@ -4286,6 +4461,13 @@
             <a:prstDash val="solid"/>
           </a:ln>
         </p:spPr>
+        <p:txBody>
+          <a:bodyPr/>
+          <a:lstStyle/>
+          <a:p>
+            <a:endParaRPr lang="en-IN"/>
+          </a:p>
+        </p:txBody>
       </p:sp>
       <p:sp>
         <p:nvSpPr>
@@ -4536,6 +4718,13 @@
           </a:gradFill>
           <a:ln/>
         </p:spPr>
+        <p:txBody>
+          <a:bodyPr/>
+          <a:lstStyle/>
+          <a:p>
+            <a:endParaRPr lang="en-IN"/>
+          </a:p>
+        </p:txBody>
       </p:sp>
       <p:sp>
         <p:nvSpPr>
@@ -4659,6 +4848,13 @@
             <a:prstDash val="solid"/>
           </a:ln>
         </p:spPr>
+        <p:txBody>
+          <a:bodyPr/>
+          <a:lstStyle/>
+          <a:p>
+            <a:endParaRPr lang="en-IN"/>
+          </a:p>
+        </p:txBody>
       </p:sp>
       <p:sp>
         <p:nvSpPr>
@@ -4679,26 +4875,13 @@
         </p:spPr>
         <p:txBody>
           <a:bodyPr wrap="square" lIns="0" tIns="0" rIns="0" bIns="0" rtlCol="0" anchor="t">
-            <a:normAutofit/>
-          </a:bodyPr>
-          <a:lstStyle/>
-          <a:p>
-            <a:pPr marL="0" indent="0" algn="l">
-              <a:lnSpc>
-                <a:spcPts val="3960"/>
-              </a:lnSpc>
-              <a:buNone/>
-            </a:pPr>
-            <a:r>
-              <a:rPr lang="en-US" sz="3600" b="1" dirty="0">
-                <a:solidFill>
-                  <a:srgbClr val="3FD8F0"/>
-                </a:solidFill>
-                <a:latin typeface="Fredoka" pitchFamily="34" charset="0"/>
-                <a:ea typeface="Fredoka" pitchFamily="34" charset="-122"/>
-                <a:cs typeface="Fredoka" pitchFamily="34" charset="-120"/>
-              </a:rPr>
-              <a:t>[___]</a:t>
+            <a:normAutofit lnSpcReduction="10000"/>
+          </a:bodyPr>
+          <a:lstStyle/>
+          <a:p>
+            <a:r>
+              <a:rPr lang="en-IN" sz="3600" dirty="0"/>
+              <a:t>12,000</a:t>
             </a:r>
             <a:endParaRPr lang="en-US" sz="3600" dirty="0"/>
           </a:p>
@@ -4778,6 +4961,13 @@
             <a:prstDash val="solid"/>
           </a:ln>
         </p:spPr>
+        <p:txBody>
+          <a:bodyPr/>
+          <a:lstStyle/>
+          <a:p>
+            <a:endParaRPr lang="en-IN"/>
+          </a:p>
+        </p:txBody>
       </p:sp>
       <p:sp>
         <p:nvSpPr>
@@ -4798,26 +4988,13 @@
         </p:spPr>
         <p:txBody>
           <a:bodyPr wrap="square" lIns="0" tIns="0" rIns="0" bIns="0" rtlCol="0" anchor="t">
-            <a:normAutofit/>
-          </a:bodyPr>
-          <a:lstStyle/>
-          <a:p>
-            <a:pPr marL="0" indent="0" algn="l">
-              <a:lnSpc>
-                <a:spcPts val="3960"/>
-              </a:lnSpc>
-              <a:buNone/>
-            </a:pPr>
-            <a:r>
-              <a:rPr lang="en-US" sz="3600" b="1" dirty="0">
-                <a:solidFill>
-                  <a:srgbClr val="3FD8F0"/>
-                </a:solidFill>
-                <a:latin typeface="Fredoka" pitchFamily="34" charset="0"/>
-                <a:ea typeface="Fredoka" pitchFamily="34" charset="-122"/>
-                <a:cs typeface="Fredoka" pitchFamily="34" charset="-120"/>
-              </a:rPr>
-              <a:t>[___]</a:t>
+            <a:normAutofit lnSpcReduction="10000"/>
+          </a:bodyPr>
+          <a:lstStyle/>
+          <a:p>
+            <a:r>
+              <a:rPr lang="en-IN" sz="3600" dirty="0"/>
+              <a:t>20</a:t>
             </a:r>
             <a:endParaRPr lang="en-US" sz="3600" dirty="0"/>
           </a:p>
@@ -4897,6 +5074,13 @@
             <a:prstDash val="solid"/>
           </a:ln>
         </p:spPr>
+        <p:txBody>
+          <a:bodyPr/>
+          <a:lstStyle/>
+          <a:p>
+            <a:endParaRPr lang="en-IN"/>
+          </a:p>
+        </p:txBody>
       </p:sp>
       <p:sp>
         <p:nvSpPr>
@@ -4906,37 +5090,24 @@
         </p:nvSpPr>
         <p:spPr>
           <a:xfrm>
-            <a:off x="6430433" y="2127647"/>
-            <a:ext cx="2084239" cy="528307"/>
-          </a:xfrm>
-          <a:prstGeom prst="rect">
-            <a:avLst/>
-          </a:prstGeom>
-          <a:noFill/>
-          <a:ln/>
-        </p:spPr>
-        <p:txBody>
-          <a:bodyPr wrap="square" lIns="0" tIns="0" rIns="0" bIns="0" rtlCol="0" anchor="t">
-            <a:normAutofit/>
-          </a:bodyPr>
-          <a:lstStyle/>
-          <a:p>
-            <a:pPr marL="0" indent="0" algn="l">
-              <a:lnSpc>
-                <a:spcPts val="3960"/>
-              </a:lnSpc>
-              <a:buNone/>
-            </a:pPr>
-            <a:r>
-              <a:rPr lang="en-US" sz="3600" b="1" dirty="0">
-                <a:solidFill>
-                  <a:srgbClr val="3FD8F0"/>
-                </a:solidFill>
-                <a:latin typeface="Fredoka" pitchFamily="34" charset="0"/>
-                <a:ea typeface="Fredoka" pitchFamily="34" charset="-122"/>
-                <a:cs typeface="Fredoka" pitchFamily="34" charset="-120"/>
-              </a:rPr>
-              <a:t>[___]</a:t>
+            <a:off x="6325657" y="2231761"/>
+            <a:ext cx="2293790" cy="528307"/>
+          </a:xfrm>
+          <a:prstGeom prst="rect">
+            <a:avLst/>
+          </a:prstGeom>
+          <a:noFill/>
+          <a:ln/>
+        </p:spPr>
+        <p:txBody>
+          <a:bodyPr wrap="square" lIns="0" tIns="0" rIns="0" bIns="0" rtlCol="0" anchor="t">
+            <a:normAutofit fontScale="70000" lnSpcReduction="20000"/>
+          </a:bodyPr>
+          <a:lstStyle/>
+          <a:p>
+            <a:r>
+              <a:rPr lang="en-IN" sz="3600" dirty="0"/>
+              <a:t>Jan – Apr 2026</a:t>
             </a:r>
             <a:endParaRPr lang="en-US" sz="3600" dirty="0"/>
           </a:p>
@@ -5016,6 +5187,13 @@
             <a:prstDash val="solid"/>
           </a:ln>
         </p:spPr>
+        <p:txBody>
+          <a:bodyPr/>
+          <a:lstStyle/>
+          <a:p>
+            <a:endParaRPr lang="en-IN"/>
+          </a:p>
+        </p:txBody>
       </p:sp>
       <p:sp>
         <p:nvSpPr>
@@ -5025,37 +5203,24 @@
         </p:nvSpPr>
         <p:spPr>
           <a:xfrm>
-            <a:off x="9122834" y="2127647"/>
-            <a:ext cx="2084239" cy="528307"/>
-          </a:xfrm>
-          <a:prstGeom prst="rect">
-            <a:avLst/>
-          </a:prstGeom>
-          <a:noFill/>
-          <a:ln/>
-        </p:spPr>
-        <p:txBody>
-          <a:bodyPr wrap="square" lIns="0" tIns="0" rIns="0" bIns="0" rtlCol="0" anchor="t">
-            <a:normAutofit/>
-          </a:bodyPr>
-          <a:lstStyle/>
-          <a:p>
-            <a:pPr marL="0" indent="0" algn="l">
-              <a:lnSpc>
-                <a:spcPts val="3960"/>
-              </a:lnSpc>
-              <a:buNone/>
-            </a:pPr>
-            <a:r>
-              <a:rPr lang="en-US" sz="3600" b="1" dirty="0">
-                <a:solidFill>
-                  <a:srgbClr val="3FD8F0"/>
-                </a:solidFill>
-                <a:latin typeface="Fredoka" pitchFamily="34" charset="0"/>
-                <a:ea typeface="Fredoka" pitchFamily="34" charset="-122"/>
-                <a:cs typeface="Fredoka" pitchFamily="34" charset="-120"/>
-              </a:rPr>
-              <a:t>[___]</a:t>
+            <a:off x="9018312" y="2201039"/>
+            <a:ext cx="2360888" cy="528307"/>
+          </a:xfrm>
+          <a:prstGeom prst="rect">
+            <a:avLst/>
+          </a:prstGeom>
+          <a:noFill/>
+          <a:ln/>
+        </p:spPr>
+        <p:txBody>
+          <a:bodyPr wrap="square" lIns="0" tIns="0" rIns="0" bIns="0" rtlCol="0" anchor="t">
+            <a:normAutofit fontScale="47500" lnSpcReduction="20000"/>
+          </a:bodyPr>
+          <a:lstStyle/>
+          <a:p>
+            <a:r>
+              <a:rPr lang="en-IN" sz="3600" dirty="0"/>
+              <a:t>Student Satisfaction (1.0 - 5.0)</a:t>
             </a:r>
             <a:endParaRPr lang="en-US" sz="3600" dirty="0"/>
           </a:p>
@@ -5135,6 +5300,13 @@
             <a:prstDash val="solid"/>
           </a:ln>
         </p:spPr>
+        <p:txBody>
+          <a:bodyPr/>
+          <a:lstStyle/>
+          <a:p>
+            <a:endParaRPr lang="en-IN"/>
+          </a:p>
+        </p:txBody>
       </p:sp>
       <p:sp>
         <p:nvSpPr>
@@ -5144,7 +5316,7 @@
         </p:nvSpPr>
         <p:spPr>
           <a:xfrm>
-            <a:off x="1071033" y="3675328"/>
+            <a:off x="1071033" y="3497348"/>
             <a:ext cx="10351432" cy="330200"/>
           </a:xfrm>
           <a:prstGeom prst="rect">
@@ -5188,82 +5360,140 @@
         </p:nvSpPr>
         <p:spPr>
           <a:xfrm>
-            <a:off x="1142153" y="4081728"/>
-            <a:ext cx="10272692" cy="882650"/>
-          </a:xfrm>
-          <a:prstGeom prst="rect">
-            <a:avLst/>
-          </a:prstGeom>
-          <a:noFill/>
-          <a:ln/>
-        </p:spPr>
-        <p:txBody>
-          <a:bodyPr wrap="square" lIns="0" tIns="0" rIns="0" bIns="0" rtlCol="0" anchor="t">
-            <a:normAutofit/>
-          </a:bodyPr>
-          <a:lstStyle/>
-          <a:p>
-            <a:pPr marL="182880" indent="-182880" algn="l">
-              <a:lnSpc>
-                <a:spcPts val="2250"/>
-              </a:lnSpc>
-              <a:buSzPct val="100000"/>
-              <a:buChar char="•"/>
-            </a:pPr>
-            <a:r>
-              <a:rPr lang="en-US" sz="1500" dirty="0">
-                <a:solidFill>
-                  <a:srgbClr val="E4E0FF"/>
-                </a:solidFill>
-                <a:latin typeface="DM Sans" pitchFamily="34" charset="0"/>
-                <a:ea typeface="DM Sans" pitchFamily="34" charset="-122"/>
-                <a:cs typeface="DM Sans" pitchFamily="34" charset="-120"/>
-              </a:rPr>
-              <a:t>[Missing values and duplicates: how you handled them]</a:t>
-            </a:r>
-            <a:endParaRPr lang="en-US" sz="1500" dirty="0"/>
-          </a:p>
-          <a:p>
-            <a:pPr marL="182880" indent="-182880" algn="l">
-              <a:lnSpc>
-                <a:spcPts val="2250"/>
-              </a:lnSpc>
-              <a:buSzPct val="100000"/>
-              <a:buChar char="•"/>
-            </a:pPr>
-            <a:r>
-              <a:rPr lang="en-US" sz="1500" dirty="0">
-                <a:solidFill>
-                  <a:srgbClr val="E4E0FF"/>
-                </a:solidFill>
-                <a:latin typeface="DM Sans" pitchFamily="34" charset="0"/>
-                <a:ea typeface="DM Sans" pitchFamily="34" charset="-122"/>
-                <a:cs typeface="DM Sans" pitchFamily="34" charset="-120"/>
-              </a:rPr>
-              <a:t>[Columns you created or transformed]</a:t>
-            </a:r>
-            <a:endParaRPr lang="en-US" sz="1500" dirty="0"/>
-          </a:p>
-          <a:p>
-            <a:pPr marL="182880" indent="-182880" algn="l">
-              <a:lnSpc>
-                <a:spcPts val="2250"/>
-              </a:lnSpc>
-              <a:buSzPct val="100000"/>
-              <a:buChar char="•"/>
-            </a:pPr>
-            <a:r>
-              <a:rPr lang="en-US" sz="1500" dirty="0">
-                <a:solidFill>
-                  <a:srgbClr val="E4E0FF"/>
-                </a:solidFill>
-                <a:latin typeface="DM Sans" pitchFamily="34" charset="0"/>
-                <a:ea typeface="DM Sans" pitchFamily="34" charset="-122"/>
-                <a:cs typeface="DM Sans" pitchFamily="34" charset="-120"/>
-              </a:rPr>
-              <a:t>[Filters or aggregations applied before charting]</a:t>
-            </a:r>
-            <a:endParaRPr lang="en-US" sz="1500" dirty="0"/>
+            <a:off x="854878" y="3904159"/>
+            <a:ext cx="10640435" cy="1362870"/>
+          </a:xfrm>
+          <a:prstGeom prst="rect">
+            <a:avLst/>
+          </a:prstGeom>
+          <a:noFill/>
+          <a:ln/>
+        </p:spPr>
+        <p:txBody>
+          <a:bodyPr wrap="square" lIns="0" tIns="0" rIns="0" bIns="0" rtlCol="0" anchor="t">
+            <a:normAutofit lnSpcReduction="10000"/>
+          </a:bodyPr>
+          <a:lstStyle/>
+          <a:p>
+            <a:pPr lvl="0"/>
+            <a:r>
+              <a:rPr lang="en-IN" sz="1100" b="1" dirty="0"/>
+              <a:t>Missing values and duplicates:</a:t>
+            </a:r>
+            <a:r>
+              <a:rPr lang="en-IN" sz="1100" dirty="0"/>
+              <a:t> Handled 96 missing </a:t>
+            </a:r>
+            <a:r>
+              <a:rPr lang="en-IN" sz="1200" dirty="0"/>
+              <a:t>Weather</a:t>
+            </a:r>
+            <a:r>
+              <a:rPr lang="en-IN" sz="1100" dirty="0"/>
+              <a:t> records, 72 </a:t>
+            </a:r>
+            <a:r>
+              <a:rPr lang="en-IN" sz="1200" dirty="0"/>
+              <a:t>Vehicle_Count</a:t>
+            </a:r>
+            <a:r>
+              <a:rPr lang="en-IN" sz="1100" dirty="0"/>
+              <a:t> nulls, and 120 </a:t>
+            </a:r>
+            <a:r>
+              <a:rPr lang="en-IN" sz="1200" dirty="0" err="1"/>
+              <a:t>Student_Satisfaction</a:t>
+            </a:r>
+            <a:r>
+              <a:rPr lang="en-IN" sz="1100" dirty="0"/>
+              <a:t> nulls using median/mode imputation; 0 duplicate records found.</a:t>
+            </a:r>
+          </a:p>
+          <a:p>
+            <a:pPr lvl="0"/>
+            <a:endParaRPr lang="en-IN" sz="1100" dirty="0"/>
+          </a:p>
+          <a:p>
+            <a:pPr lvl="0"/>
+            <a:r>
+              <a:rPr lang="en-IN" sz="1100" b="1" dirty="0"/>
+              <a:t>Columns created or transformed:</a:t>
+            </a:r>
+            <a:r>
+              <a:rPr lang="en-IN" sz="1100" dirty="0"/>
+              <a:t> Extracted integer </a:t>
+            </a:r>
+            <a:r>
+              <a:rPr lang="en-IN" sz="1200" dirty="0"/>
+              <a:t>Hour</a:t>
+            </a:r>
+            <a:r>
+              <a:rPr lang="en-IN" sz="1100" dirty="0"/>
+              <a:t> from time stamps, derived </a:t>
+            </a:r>
+            <a:r>
+              <a:rPr lang="en-IN" sz="1200" dirty="0"/>
+              <a:t>Shuttle_Deficit</a:t>
+            </a:r>
+            <a:r>
+              <a:rPr lang="en-IN" sz="1100" dirty="0"/>
+              <a:t> (</a:t>
+            </a:r>
+            <a:r>
+              <a:rPr lang="en-IN" sz="1200" dirty="0"/>
+              <a:t>Demand - Capacity</a:t>
+            </a:r>
+            <a:r>
+              <a:rPr lang="en-IN" sz="1100" dirty="0"/>
+              <a:t>), and engineered </a:t>
+            </a:r>
+            <a:r>
+              <a:rPr lang="en-IN" sz="1200" dirty="0" err="1"/>
+              <a:t>Transition_Bin</a:t>
+            </a:r>
+            <a:r>
+              <a:rPr lang="en-IN" sz="1100" dirty="0"/>
+              <a:t> for class surge intensity.</a:t>
+            </a:r>
+          </a:p>
+          <a:p>
+            <a:pPr lvl="0"/>
+            <a:endParaRPr lang="en-IN" sz="1100" dirty="0"/>
+          </a:p>
+          <a:p>
+            <a:pPr lvl="0"/>
+            <a:r>
+              <a:rPr lang="en-IN" sz="1100" b="1" dirty="0"/>
+              <a:t>Filters or aggregations applied before charting:</a:t>
+            </a:r>
+            <a:r>
+              <a:rPr lang="en-IN" sz="1100" dirty="0"/>
+              <a:t> Grouped by </a:t>
+            </a:r>
+            <a:r>
+              <a:rPr lang="en-IN" sz="1200" dirty="0"/>
+              <a:t>Zone</a:t>
+            </a:r>
+            <a:r>
+              <a:rPr lang="en-IN" sz="1100" dirty="0"/>
+              <a:t>, </a:t>
+            </a:r>
+            <a:r>
+              <a:rPr lang="en-IN" sz="1200" dirty="0"/>
+              <a:t>Hour</a:t>
+            </a:r>
+            <a:r>
+              <a:rPr lang="en-IN" sz="1100" dirty="0"/>
+              <a:t>, and </a:t>
+            </a:r>
+            <a:r>
+              <a:rPr lang="en-IN" sz="1200" dirty="0" err="1"/>
+              <a:t>Week_Type</a:t>
+            </a:r>
+            <a:r>
+              <a:rPr lang="en-IN" sz="1100" dirty="0"/>
+              <a:t> to aggregate mean footfall, transit overcapacity, and canteen queue wait times.</a:t>
+            </a:r>
           </a:p>
         </p:txBody>
       </p:sp>
@@ -5418,6 +5648,13 @@
           </a:gradFill>
           <a:ln/>
         </p:spPr>
+        <p:txBody>
+          <a:bodyPr/>
+          <a:lstStyle/>
+          <a:p>
+            <a:endParaRPr lang="en-IN"/>
+          </a:p>
+        </p:txBody>
       </p:sp>
       <p:sp>
         <p:nvSpPr>
@@ -5541,6 +5778,13 @@
             <a:prstDash val="solid"/>
           </a:ln>
         </p:spPr>
+        <p:txBody>
+          <a:bodyPr/>
+          <a:lstStyle/>
+          <a:p>
+            <a:endParaRPr lang="en-IN"/>
+          </a:p>
+        </p:txBody>
       </p:sp>
       <p:sp>
         <p:nvSpPr>
@@ -5704,6 +5948,13 @@
             <a:prstDash val="solid"/>
           </a:ln>
         </p:spPr>
+        <p:txBody>
+          <a:bodyPr/>
+          <a:lstStyle/>
+          <a:p>
+            <a:endParaRPr lang="en-IN"/>
+          </a:p>
+        </p:txBody>
       </p:sp>
       <p:sp>
         <p:nvSpPr>
@@ -5867,6 +6118,13 @@
             <a:prstDash val="solid"/>
           </a:ln>
         </p:spPr>
+        <p:txBody>
+          <a:bodyPr/>
+          <a:lstStyle/>
+          <a:p>
+            <a:endParaRPr lang="en-IN"/>
+          </a:p>
+        </p:txBody>
       </p:sp>
       <p:sp>
         <p:nvSpPr>
@@ -6030,6 +6288,13 @@
             <a:prstDash val="solid"/>
           </a:ln>
         </p:spPr>
+        <p:txBody>
+          <a:bodyPr/>
+          <a:lstStyle/>
+          <a:p>
+            <a:endParaRPr lang="en-IN"/>
+          </a:p>
+        </p:txBody>
       </p:sp>
       <p:sp>
         <p:nvSpPr>
@@ -6193,6 +6458,13 @@
             <a:prstDash val="solid"/>
           </a:ln>
         </p:spPr>
+        <p:txBody>
+          <a:bodyPr/>
+          <a:lstStyle/>
+          <a:p>
+            <a:endParaRPr lang="en-IN"/>
+          </a:p>
+        </p:txBody>
       </p:sp>
       <p:sp>
         <p:nvSpPr>
@@ -6433,6 +6705,13 @@
           </a:gradFill>
           <a:ln/>
         </p:spPr>
+        <p:txBody>
+          <a:bodyPr/>
+          <a:lstStyle/>
+          <a:p>
+            <a:endParaRPr lang="en-IN"/>
+          </a:p>
+        </p:txBody>
       </p:sp>
       <p:sp>
         <p:nvSpPr>
@@ -6611,6 +6890,13 @@
             <a:prstDash val="solid"/>
           </a:ln>
         </p:spPr>
+        <p:txBody>
+          <a:bodyPr/>
+          <a:lstStyle/>
+          <a:p>
+            <a:endParaRPr lang="en-IN"/>
+          </a:p>
+        </p:txBody>
       </p:sp>
       <p:sp>
         <p:nvSpPr>
@@ -6894,6 +7180,13 @@
           </a:gradFill>
           <a:ln/>
         </p:spPr>
+        <p:txBody>
+          <a:bodyPr/>
+          <a:lstStyle/>
+          <a:p>
+            <a:endParaRPr lang="en-IN"/>
+          </a:p>
+        </p:txBody>
       </p:sp>
       <p:sp>
         <p:nvSpPr>
@@ -7336,6 +7629,13 @@
           </a:gradFill>
           <a:ln/>
         </p:spPr>
+        <p:txBody>
+          <a:bodyPr/>
+          <a:lstStyle/>
+          <a:p>
+            <a:endParaRPr lang="en-IN"/>
+          </a:p>
+        </p:txBody>
       </p:sp>
       <p:sp>
         <p:nvSpPr>
@@ -7459,6 +7759,13 @@
             <a:prstDash val="solid"/>
           </a:ln>
         </p:spPr>
+        <p:txBody>
+          <a:bodyPr/>
+          <a:lstStyle/>
+          <a:p>
+            <a:endParaRPr lang="en-IN"/>
+          </a:p>
+        </p:txBody>
       </p:sp>
       <p:sp>
         <p:nvSpPr>
@@ -7622,6 +7929,13 @@
             <a:prstDash val="solid"/>
           </a:ln>
         </p:spPr>
+        <p:txBody>
+          <a:bodyPr/>
+          <a:lstStyle/>
+          <a:p>
+            <a:endParaRPr lang="en-IN"/>
+          </a:p>
+        </p:txBody>
       </p:sp>
       <p:sp>
         <p:nvSpPr>
@@ -7785,6 +8099,13 @@
             <a:prstDash val="solid"/>
           </a:ln>
         </p:spPr>
+        <p:txBody>
+          <a:bodyPr/>
+          <a:lstStyle/>
+          <a:p>
+            <a:endParaRPr lang="en-IN"/>
+          </a:p>
+        </p:txBody>
       </p:sp>
       <p:sp>
         <p:nvSpPr>
@@ -8069,6 +8390,13 @@
           </a:gradFill>
           <a:ln/>
         </p:spPr>
+        <p:txBody>
+          <a:bodyPr/>
+          <a:lstStyle/>
+          <a:p>
+            <a:endParaRPr lang="en-IN"/>
+          </a:p>
+        </p:txBody>
       </p:sp>
       <p:sp>
         <p:nvSpPr>
@@ -8192,6 +8520,13 @@
             <a:prstDash val="solid"/>
           </a:ln>
         </p:spPr>
+        <p:txBody>
+          <a:bodyPr/>
+          <a:lstStyle/>
+          <a:p>
+            <a:endParaRPr lang="en-IN"/>
+          </a:p>
+        </p:txBody>
       </p:sp>
       <p:sp>
         <p:nvSpPr>
@@ -8354,6 +8689,13 @@
             <a:prstDash val="solid"/>
           </a:ln>
         </p:spPr>
+        <p:txBody>
+          <a:bodyPr/>
+          <a:lstStyle/>
+          <a:p>
+            <a:endParaRPr lang="en-IN"/>
+          </a:p>
+        </p:txBody>
       </p:sp>
       <p:sp>
         <p:nvSpPr>

</xml_diff>